<commit_message>
Reissue the Keen Thailand memo, translation and deck at 100 percent replacement
Every figure regenerated from the six new workbooks (55 large numbers
machine-traced to the workbook set; EN and VI carry identical figures).
Storage conclusion restated from this solve: still selected at the third
price point, 367 and 1,881 kWh. New section on the year-10 replacement
falling in the final debt year (case 6 coverage 0.64 in that year), a
replacement subsection and the degradation check in the technical basis.
Deck slides 8 and 10 updated; no stale figure remains. HTML artifact
redeployed to the same URL.

Co-Authored-By: Claude Opus 5 <noreply@anthropic.com>
</commit_message>
<xml_diff>
--- a/outputs/thailand_case/rofu_thailand/Rofu_Thailand_Tariff_Structure_Internal.pptx
+++ b/outputs/thailand_case/rofu_thailand/Rofu_Thailand_Tariff_Structure_Internal.pptx
@@ -1747,6 +1747,10 @@
             <a:prstDash val="solid"/>
           </a:ln>
         </p:spPr>
+        <p:txBody xmlns:a="http://schemas.openxmlformats.org/drawingml/2006/main">
+          <a:bodyPr/>
+          <a:p/>
+        </p:txBody>
       </p:sp>
       <p:sp>
         <p:nvSpPr>
@@ -1858,6 +1862,10 @@
             <a:prstDash val="solid"/>
           </a:ln>
         </p:spPr>
+        <p:txBody xmlns:a="http://schemas.openxmlformats.org/drawingml/2006/main">
+          <a:bodyPr/>
+          <a:p/>
+        </p:txBody>
       </p:sp>
       <p:sp>
         <p:nvSpPr>
@@ -2065,6 +2073,10 @@
           <a:effectRef xmlns:a="http://schemas.openxmlformats.org/drawingml/2006/main" idx="4"/>
           <a:fontRef xmlns:a="http://schemas.openxmlformats.org/drawingml/2006/main" idx="major"/>
         </p:style>
+        <p:txBody xmlns:a="http://schemas.openxmlformats.org/drawingml/2006/main">
+          <a:bodyPr/>
+          <a:p/>
+        </p:txBody>
       </p:sp>
       <p:sp>
         <p:nvSpPr>
@@ -2460,6 +2472,10 @@
             <a:prstDash val="solid"/>
           </a:ln>
         </p:spPr>
+        <p:txBody xmlns:a="http://schemas.openxmlformats.org/drawingml/2006/main">
+          <a:bodyPr/>
+          <a:p/>
+        </p:txBody>
       </p:sp>
       <p:sp>
         <p:nvSpPr>
@@ -2662,6 +2678,10 @@
             <a:prstDash val="solid"/>
           </a:ln>
         </p:spPr>
+        <p:txBody xmlns:a="http://schemas.openxmlformats.org/drawingml/2006/main">
+          <a:bodyPr/>
+          <a:p/>
+        </p:txBody>
       </p:sp>
       <p:sp>
         <p:nvSpPr>
@@ -2829,7 +2849,7 @@
                 <a:ea typeface="Arial"/>
                 <a:cs typeface="Arial"/>
               </a:rPr>
-              <a:t>At the confirmed battery price the model selects storage in both cases that permit it. Our earlier no-battery advice is withdrawn.</a:t>
+              <a:t>At the confirmed battery price, with a full-price year-10 replacement, the model selects storage in both cases that permit it. Our earlier no-battery advice stays withdrawn.</a:t>
             </a:r>
           </a:p>
         </p:txBody>
@@ -2864,6 +2884,10 @@
             <a:prstDash val="solid"/>
           </a:ln>
         </p:spPr>
+        <p:txBody xmlns:a="http://schemas.openxmlformats.org/drawingml/2006/main">
+          <a:bodyPr/>
+          <a:p/>
+        </p:txBody>
       </p:sp>
       <p:sp>
         <p:nvSpPr>
@@ -3105,6 +3129,10 @@
           <a:effectRef xmlns:a="http://schemas.openxmlformats.org/drawingml/2006/main" idx="4"/>
           <a:fontRef xmlns:a="http://schemas.openxmlformats.org/drawingml/2006/main" idx="major"/>
         </p:style>
+        <p:txBody xmlns:a="http://schemas.openxmlformats.org/drawingml/2006/main">
+          <a:bodyPr/>
+          <a:p/>
+        </p:txBody>
       </p:sp>
       <p:sp>
         <p:nvSpPr>
@@ -3447,6 +3475,10 @@
             <a:prstDash val="solid"/>
           </a:ln>
         </p:spPr>
+        <p:txBody xmlns:a="http://schemas.openxmlformats.org/drawingml/2006/main">
+          <a:bodyPr/>
+          <a:p/>
+        </p:txBody>
       </p:sp>
       <p:sp>
         <p:nvSpPr>
@@ -3857,6 +3889,10 @@
             <a:prstDash val="solid"/>
           </a:ln>
         </p:spPr>
+        <p:txBody xmlns:a="http://schemas.openxmlformats.org/drawingml/2006/main">
+          <a:bodyPr/>
+          <a:p/>
+        </p:txBody>
       </p:sp>
       <p:sp>
         <p:nvSpPr>
@@ -3949,6 +3985,10 @@
             <a:prstDash val="solid"/>
           </a:ln>
         </p:spPr>
+        <p:txBody xmlns:a="http://schemas.openxmlformats.org/drawingml/2006/main">
+          <a:bodyPr/>
+          <a:p/>
+        </p:txBody>
       </p:sp>
       <p:sp>
         <p:nvSpPr>
@@ -4041,6 +4081,10 @@
             <a:prstDash val="solid"/>
           </a:ln>
         </p:spPr>
+        <p:txBody xmlns:a="http://schemas.openxmlformats.org/drawingml/2006/main">
+          <a:bodyPr/>
+          <a:p/>
+        </p:txBody>
       </p:sp>
       <p:sp>
         <p:nvSpPr>
@@ -4133,6 +4177,10 @@
             <a:prstDash val="solid"/>
           </a:ln>
         </p:spPr>
+        <p:txBody xmlns:a="http://schemas.openxmlformats.org/drawingml/2006/main">
+          <a:bodyPr/>
+          <a:p/>
+        </p:txBody>
       </p:sp>
       <p:sp>
         <p:nvSpPr>
@@ -4374,6 +4422,10 @@
           <a:effectRef xmlns:a="http://schemas.openxmlformats.org/drawingml/2006/main" idx="4"/>
           <a:fontRef xmlns:a="http://schemas.openxmlformats.org/drawingml/2006/main" idx="major"/>
         </p:style>
+        <p:txBody xmlns:a="http://schemas.openxmlformats.org/drawingml/2006/main">
+          <a:bodyPr/>
+          <a:p/>
+        </p:txBody>
       </p:sp>
       <p:sp>
         <p:nvSpPr>
@@ -4659,6 +4711,10 @@
             <a:prstDash val="solid"/>
           </a:ln>
         </p:spPr>
+        <p:txBody xmlns:a="http://schemas.openxmlformats.org/drawingml/2006/main">
+          <a:bodyPr/>
+          <a:p/>
+        </p:txBody>
       </p:sp>
       <p:sp>
         <p:nvSpPr>
@@ -4808,6 +4864,10 @@
             <a:prstDash val="solid"/>
           </a:ln>
         </p:spPr>
+        <p:txBody xmlns:a="http://schemas.openxmlformats.org/drawingml/2006/main">
+          <a:bodyPr/>
+          <a:p/>
+        </p:txBody>
       </p:sp>
       <p:sp>
         <p:nvSpPr>
@@ -4957,6 +5017,10 @@
             <a:prstDash val="solid"/>
           </a:ln>
         </p:spPr>
+        <p:txBody xmlns:a="http://schemas.openxmlformats.org/drawingml/2006/main">
+          <a:bodyPr/>
+          <a:p/>
+        </p:txBody>
       </p:sp>
       <p:sp>
         <p:nvSpPr>
@@ -5106,6 +5170,10 @@
             <a:prstDash val="solid"/>
           </a:ln>
         </p:spPr>
+        <p:txBody xmlns:a="http://schemas.openxmlformats.org/drawingml/2006/main">
+          <a:bodyPr/>
+          <a:p/>
+        </p:txBody>
       </p:sp>
       <p:sp>
         <p:nvSpPr>
@@ -5255,6 +5323,10 @@
             <a:prstDash val="solid"/>
           </a:ln>
         </p:spPr>
+        <p:txBody xmlns:a="http://schemas.openxmlformats.org/drawingml/2006/main">
+          <a:bodyPr/>
+          <a:p/>
+        </p:txBody>
       </p:sp>
       <p:sp>
         <p:nvSpPr>
@@ -5632,6 +5704,10 @@
             <a:prstDash val="solid"/>
           </a:ln>
         </p:spPr>
+        <p:txBody xmlns:a="http://schemas.openxmlformats.org/drawingml/2006/main">
+          <a:bodyPr/>
+          <a:p/>
+        </p:txBody>
       </p:sp>
       <p:sp>
         <p:nvSpPr>
@@ -5930,6 +6006,10 @@
           <a:effectRef xmlns:a="http://schemas.openxmlformats.org/drawingml/2006/main" idx="4"/>
           <a:fontRef xmlns:a="http://schemas.openxmlformats.org/drawingml/2006/main" idx="major"/>
         </p:style>
+        <p:txBody xmlns:a="http://schemas.openxmlformats.org/drawingml/2006/main">
+          <a:bodyPr/>
+          <a:p/>
+        </p:txBody>
       </p:sp>
       <p:sp>
         <p:nvSpPr>
@@ -6215,6 +6295,10 @@
             <a:prstDash val="solid"/>
           </a:ln>
         </p:spPr>
+        <p:txBody xmlns:a="http://schemas.openxmlformats.org/drawingml/2006/main">
+          <a:bodyPr/>
+          <a:p/>
+        </p:txBody>
       </p:sp>
       <p:sp>
         <p:nvSpPr>
@@ -6248,6 +6332,10 @@
             <a:prstDash val="solid"/>
           </a:ln>
         </p:spPr>
+        <p:txBody xmlns:a="http://schemas.openxmlformats.org/drawingml/2006/main">
+          <a:bodyPr/>
+          <a:p/>
+        </p:txBody>
       </p:sp>
       <p:sp>
         <p:nvSpPr>
@@ -6283,6 +6371,10 @@
             <a:prstDash val="solid"/>
           </a:ln>
         </p:spPr>
+        <p:txBody xmlns:a="http://schemas.openxmlformats.org/drawingml/2006/main">
+          <a:bodyPr/>
+          <a:p/>
+        </p:txBody>
       </p:sp>
       <p:sp>
         <p:nvSpPr>
@@ -6911,6 +7003,10 @@
             <a:prstDash val="solid"/>
           </a:ln>
         </p:spPr>
+        <p:txBody xmlns:a="http://schemas.openxmlformats.org/drawingml/2006/main">
+          <a:bodyPr/>
+          <a:p/>
+        </p:txBody>
       </p:sp>
       <p:sp>
         <p:nvSpPr>
@@ -7003,6 +7099,10 @@
             <a:prstDash val="solid"/>
           </a:ln>
         </p:spPr>
+        <p:txBody xmlns:a="http://schemas.openxmlformats.org/drawingml/2006/main">
+          <a:bodyPr/>
+          <a:p/>
+        </p:txBody>
       </p:sp>
       <p:sp>
         <p:nvSpPr>
@@ -7187,6 +7287,10 @@
           <a:effectRef xmlns:a="http://schemas.openxmlformats.org/drawingml/2006/main" idx="4"/>
           <a:fontRef xmlns:a="http://schemas.openxmlformats.org/drawingml/2006/main" idx="major"/>
         </p:style>
+        <p:txBody xmlns:a="http://schemas.openxmlformats.org/drawingml/2006/main">
+          <a:bodyPr/>
+          <a:p/>
+        </p:txBody>
       </p:sp>
       <p:sp>
         <p:nvSpPr>
@@ -7584,6 +7688,10 @@
             <a:prstDash val="solid"/>
           </a:ln>
         </p:spPr>
+        <p:txBody xmlns:a="http://schemas.openxmlformats.org/drawingml/2006/main">
+          <a:bodyPr/>
+          <a:p/>
+        </p:txBody>
       </p:sp>
       <p:sp>
         <p:nvSpPr>
@@ -7788,6 +7896,10 @@
             <a:prstDash val="solid"/>
           </a:ln>
         </p:spPr>
+        <p:txBody xmlns:a="http://schemas.openxmlformats.org/drawingml/2006/main">
+          <a:bodyPr/>
+          <a:p/>
+        </p:txBody>
       </p:sp>
       <p:sp>
         <p:nvSpPr>
@@ -7992,6 +8104,10 @@
             <a:prstDash val="solid"/>
           </a:ln>
         </p:spPr>
+        <p:txBody xmlns:a="http://schemas.openxmlformats.org/drawingml/2006/main">
+          <a:bodyPr/>
+          <a:p/>
+        </p:txBody>
       </p:sp>
       <p:sp>
         <p:nvSpPr>
@@ -8196,6 +8312,10 @@
             <a:prstDash val="solid"/>
           </a:ln>
         </p:spPr>
+        <p:txBody xmlns:a="http://schemas.openxmlformats.org/drawingml/2006/main">
+          <a:bodyPr/>
+          <a:p/>
+        </p:txBody>
       </p:sp>
       <p:sp>
         <p:nvSpPr>
@@ -8400,6 +8520,10 @@
             <a:prstDash val="solid"/>
           </a:ln>
         </p:spPr>
+        <p:txBody xmlns:a="http://schemas.openxmlformats.org/drawingml/2006/main">
+          <a:bodyPr/>
+          <a:p/>
+        </p:txBody>
       </p:sp>
       <p:sp>
         <p:nvSpPr>
@@ -8698,6 +8822,10 @@
           <a:effectRef xmlns:a="http://schemas.openxmlformats.org/drawingml/2006/main" idx="4"/>
           <a:fontRef xmlns:a="http://schemas.openxmlformats.org/drawingml/2006/main" idx="major"/>
         </p:style>
+        <p:txBody xmlns:a="http://schemas.openxmlformats.org/drawingml/2006/main">
+          <a:bodyPr/>
+          <a:p/>
+        </p:txBody>
       </p:sp>
       <p:sp>
         <p:nvSpPr>
@@ -9065,6 +9193,10 @@
             <a:prstDash val="solid"/>
           </a:ln>
         </p:spPr>
+        <p:txBody xmlns:a="http://schemas.openxmlformats.org/drawingml/2006/main">
+          <a:bodyPr/>
+          <a:p/>
+        </p:txBody>
       </p:sp>
       <p:sp>
         <p:nvSpPr>
@@ -9155,6 +9287,10 @@
             <a:prstDash val="solid"/>
           </a:ln>
         </p:spPr>
+        <p:txBody xmlns:a="http://schemas.openxmlformats.org/drawingml/2006/main">
+          <a:bodyPr/>
+          <a:p/>
+        </p:txBody>
       </p:sp>
       <p:sp>
         <p:nvSpPr>
@@ -9245,6 +9381,10 @@
             <a:prstDash val="solid"/>
           </a:ln>
         </p:spPr>
+        <p:txBody xmlns:a="http://schemas.openxmlformats.org/drawingml/2006/main">
+          <a:bodyPr/>
+          <a:p/>
+        </p:txBody>
       </p:sp>
       <p:sp>
         <p:nvSpPr>
@@ -9278,6 +9418,10 @@
             <a:prstDash val="solid"/>
           </a:ln>
         </p:spPr>
+        <p:txBody xmlns:a="http://schemas.openxmlformats.org/drawingml/2006/main">
+          <a:bodyPr/>
+          <a:p/>
+        </p:txBody>
       </p:sp>
       <p:sp>
         <p:nvSpPr>
@@ -9765,6 +9909,10 @@
             <a:prstDash val="solid"/>
           </a:ln>
         </p:spPr>
+        <p:txBody xmlns:a="http://schemas.openxmlformats.org/drawingml/2006/main">
+          <a:bodyPr/>
+          <a:p/>
+        </p:txBody>
       </p:sp>
       <p:sp>
         <p:nvSpPr>
@@ -10028,6 +10176,10 @@
             <a:prstDash val="solid"/>
           </a:ln>
         </p:spPr>
+        <p:txBody xmlns:a="http://schemas.openxmlformats.org/drawingml/2006/main">
+          <a:bodyPr/>
+          <a:p/>
+        </p:txBody>
       </p:sp>
       <p:sp>
         <p:nvSpPr>
@@ -10212,6 +10364,10 @@
           <a:effectRef xmlns:a="http://schemas.openxmlformats.org/drawingml/2006/main" idx="4"/>
           <a:fontRef xmlns:a="http://schemas.openxmlformats.org/drawingml/2006/main" idx="major"/>
         </p:style>
+        <p:txBody xmlns:a="http://schemas.openxmlformats.org/drawingml/2006/main">
+          <a:bodyPr/>
+          <a:p/>
+        </p:txBody>
       </p:sp>
       <p:sp>
         <p:nvSpPr>
@@ -10554,6 +10710,10 @@
             <a:prstDash val="solid"/>
           </a:ln>
         </p:spPr>
+        <p:txBody xmlns:a="http://schemas.openxmlformats.org/drawingml/2006/main">
+          <a:bodyPr/>
+          <a:p/>
+        </p:txBody>
       </p:sp>
       <p:sp>
         <p:nvSpPr>
@@ -10646,6 +10806,10 @@
             <a:prstDash val="solid"/>
           </a:ln>
         </p:spPr>
+        <p:txBody xmlns:a="http://schemas.openxmlformats.org/drawingml/2006/main">
+          <a:bodyPr/>
+          <a:p/>
+        </p:txBody>
       </p:sp>
       <p:sp>
         <p:nvSpPr>
@@ -10795,6 +10959,10 @@
             <a:prstDash val="solid"/>
           </a:ln>
         </p:spPr>
+        <p:txBody xmlns:a="http://schemas.openxmlformats.org/drawingml/2006/main">
+          <a:bodyPr/>
+          <a:p/>
+        </p:txBody>
       </p:sp>
       <p:sp>
         <p:nvSpPr>
@@ -10887,6 +11055,10 @@
             <a:prstDash val="solid"/>
           </a:ln>
         </p:spPr>
+        <p:txBody xmlns:a="http://schemas.openxmlformats.org/drawingml/2006/main">
+          <a:bodyPr/>
+          <a:p/>
+        </p:txBody>
       </p:sp>
       <p:sp>
         <p:nvSpPr>
@@ -11036,6 +11208,10 @@
             <a:prstDash val="solid"/>
           </a:ln>
         </p:spPr>
+        <p:txBody xmlns:a="http://schemas.openxmlformats.org/drawingml/2006/main">
+          <a:bodyPr/>
+          <a:p/>
+        </p:txBody>
       </p:sp>
       <p:sp>
         <p:nvSpPr>
@@ -11128,6 +11304,10 @@
             <a:prstDash val="solid"/>
           </a:ln>
         </p:spPr>
+        <p:txBody xmlns:a="http://schemas.openxmlformats.org/drawingml/2006/main">
+          <a:bodyPr/>
+          <a:p/>
+        </p:txBody>
       </p:sp>
       <p:sp>
         <p:nvSpPr>
@@ -11277,6 +11457,10 @@
             <a:prstDash val="solid"/>
           </a:ln>
         </p:spPr>
+        <p:txBody xmlns:a="http://schemas.openxmlformats.org/drawingml/2006/main">
+          <a:bodyPr/>
+          <a:p/>
+        </p:txBody>
       </p:sp>
       <p:sp>
         <p:nvSpPr>
@@ -11369,6 +11553,10 @@
             <a:prstDash val="solid"/>
           </a:ln>
         </p:spPr>
+        <p:txBody xmlns:a="http://schemas.openxmlformats.org/drawingml/2006/main">
+          <a:bodyPr/>
+          <a:p/>
+        </p:txBody>
       </p:sp>
       <p:sp>
         <p:nvSpPr>
@@ -11553,6 +11741,10 @@
           <a:effectRef xmlns:a="http://schemas.openxmlformats.org/drawingml/2006/main" idx="4"/>
           <a:fontRef xmlns:a="http://schemas.openxmlformats.org/drawingml/2006/main" idx="major"/>
         </p:style>
+        <p:txBody xmlns:a="http://schemas.openxmlformats.org/drawingml/2006/main">
+          <a:bodyPr/>
+          <a:p/>
+        </p:txBody>
       </p:sp>
       <p:sp>
         <p:nvSpPr>
@@ -11838,6 +12030,10 @@
             <a:prstDash val="solid"/>
           </a:ln>
         </p:spPr>
+        <p:txBody xmlns:a="http://schemas.openxmlformats.org/drawingml/2006/main">
+          <a:bodyPr/>
+          <a:p/>
+        </p:txBody>
       </p:sp>
       <p:sp>
         <p:nvSpPr>
@@ -12044,6 +12240,10 @@
             <a:prstDash val="solid"/>
           </a:ln>
         </p:spPr>
+        <p:txBody xmlns:a="http://schemas.openxmlformats.org/drawingml/2006/main">
+          <a:bodyPr/>
+          <a:p/>
+        </p:txBody>
       </p:sp>
       <p:sp>
         <p:nvSpPr>
@@ -12097,7 +12297,7 @@
                 <a:ea typeface="Arial"/>
                 <a:cs typeface="Arial"/>
               </a:rPr>
-              <a:t>Re-solved 9 Sep 2026</a:t>
+              <a:t>Re-solved 12 Sep 2026</a:t>
             </a:r>
           </a:p>
         </p:txBody>
@@ -12154,7 +12354,7 @@
                 <a:ea typeface="Arial"/>
                 <a:cs typeface="Arial"/>
               </a:rPr>
-              <a:t>+0.6 pp</a:t>
+              <a:t>+1.3 pp</a:t>
             </a:r>
           </a:p>
         </p:txBody>
@@ -12382,7 +12582,7 @@
                 <a:ea typeface="Arial"/>
                 <a:cs typeface="Arial"/>
               </a:rPr>
-              <a:t>238 kW / 429 kWh BESS</a:t>
+              <a:t>222 kW / 367 kWh BESS</a:t>
             </a:r>
           </a:p>
         </p:txBody>
@@ -12439,7 +12639,7 @@
                 <a:ea typeface="Arial"/>
                 <a:cs typeface="Arial"/>
               </a:rPr>
-              <a:t>31.4% grid offset</a:t>
+              <a:t>32.1% grid offset</a:t>
             </a:r>
           </a:p>
         </p:txBody>
@@ -12474,6 +12674,10 @@
             <a:prstDash val="solid"/>
           </a:ln>
         </p:spPr>
+        <p:txBody xmlns:a="http://schemas.openxmlformats.org/drawingml/2006/main">
+          <a:bodyPr/>
+          <a:p/>
+        </p:txBody>
       </p:sp>
       <p:sp>
         <p:nvSpPr>
@@ -12584,7 +12788,7 @@
                 <a:ea typeface="Arial"/>
                 <a:cs typeface="Arial"/>
               </a:rPr>
-              <a:t>2,957 kWp PV</a:t>
+              <a:t>2,847 kWp PV</a:t>
             </a:r>
           </a:p>
         </p:txBody>
@@ -12641,7 +12845,7 @@
                 <a:ea typeface="Arial"/>
                 <a:cs typeface="Arial"/>
               </a:rPr>
-              <a:t>575 kW / 2,378 kWh BESS</a:t>
+              <a:t>507 kW / 1,881 kWh BESS</a:t>
             </a:r>
           </a:p>
         </p:txBody>
@@ -12698,7 +12902,7 @@
                 <a:ea typeface="Arial"/>
                 <a:cs typeface="Arial"/>
               </a:rPr>
-              <a:t>50.9% grid offset</a:t>
+              <a:t>50.4% grid offset</a:t>
             </a:r>
           </a:p>
         </p:txBody>
@@ -12755,7 +12959,7 @@
                 <a:ea typeface="Arial"/>
                 <a:cs typeface="Arial"/>
               </a:rPr>
-              <a:t>The model now selects a battery in both cases, neither at a modelling limit. This reverses the earlier conclusion.</a:t>
+              <a:t>The model selects a battery in both cases, neither at a modelling limit, with the battery replaced in year 10 at 100% of install cost. The conclusion has held at three price points.</a:t>
             </a:r>
           </a:p>
         </p:txBody>
@@ -12829,6 +13033,10 @@
           <a:effectRef xmlns:a="http://schemas.openxmlformats.org/drawingml/2006/main" idx="4"/>
           <a:fontRef xmlns:a="http://schemas.openxmlformats.org/drawingml/2006/main" idx="major"/>
         </p:style>
+        <p:txBody xmlns:a="http://schemas.openxmlformats.org/drawingml/2006/main">
+          <a:bodyPr/>
+          <a:p/>
+        </p:txBody>
       </p:sp>
       <p:sp>
         <p:nvSpPr>
@@ -13224,6 +13432,10 @@
             <a:prstDash val="solid"/>
           </a:ln>
         </p:spPr>
+        <p:txBody xmlns:a="http://schemas.openxmlformats.org/drawingml/2006/main">
+          <a:bodyPr/>
+          <a:p/>
+        </p:txBody>
       </p:sp>
       <p:sp>
         <p:nvSpPr>
@@ -13426,6 +13638,10 @@
             <a:prstDash val="solid"/>
           </a:ln>
         </p:spPr>
+        <p:txBody xmlns:a="http://schemas.openxmlformats.org/drawingml/2006/main">
+          <a:bodyPr/>
+          <a:p/>
+        </p:txBody>
       </p:sp>
       <p:sp>
         <p:nvSpPr>
@@ -13628,6 +13844,10 @@
             <a:prstDash val="solid"/>
           </a:ln>
         </p:spPr>
+        <p:txBody xmlns:a="http://schemas.openxmlformats.org/drawingml/2006/main">
+          <a:bodyPr/>
+          <a:p/>
+        </p:txBody>
       </p:sp>
       <p:sp>
         <p:nvSpPr>

</xml_diff>